<commit_message>
actualised pricing in docs
</commit_message>
<xml_diff>
--- a/docs/DocRobot_Private-AI_Corporate-Document-Analysis.pptx
+++ b/docs/DocRobot_Private-AI_Corporate-Document-Analysis.pptx
@@ -5010,7 +5010,7 @@
               <a:defRPr sz="3200"/>
             </a:pPr>
             <a:r>
-              <a:t>Pricing and ROI</a:t>
+              <a:t>Pricing and Operational Costs</a:t>
             </a:r>
           </a:p>
         </p:txBody>
@@ -5035,7 +5035,7 @@
               <a:defRPr sz="1700"/>
             </a:pPr>
             <a:r>
-              <a:t>One-time setup: 1,600 – 3,200 EUR</a:t>
+              <a:t>One-time setup: 2,800 – 6,400 EUR (HW included)</a:t>
             </a:r>
           </a:p>
           <a:p>
@@ -5043,7 +5043,7 @@
               <a:defRPr sz="1700"/>
             </a:pPr>
             <a:r>
-              <a:t>Monthly support &amp; updates: 60 – 300 EUR</a:t>
+              <a:t>Monthly maintenance: 0 EUR (Self-hosted mode)</a:t>
             </a:r>
           </a:p>
           <a:p>
@@ -5051,7 +5051,15 @@
               <a:defRPr sz="1700"/>
             </a:pPr>
             <a:r>
-              <a:t>ROI (Return on Investment) within 6 months</a:t>
+              <a:t>Software Updates &amp; Expert Support: Optional (On-demand)</a:t>
+            </a:r>
+          </a:p>
+          <a:p>
+            <a:pPr>
+              <a:defRPr sz="1700"/>
+            </a:pPr>
+            <a:r>
+              <a:t>ROI (Return on Investment): Within 6 months</a:t>
             </a:r>
           </a:p>
         </p:txBody>

</xml_diff>

<commit_message>
pricing moved to the end
</commit_message>
<xml_diff>
--- a/docs/DocRobot_Private-AI_Corporate-Document-Analysis.pptx
+++ b/docs/DocRobot_Private-AI_Corporate-Document-Analysis.pptx
@@ -3221,7 +3221,7 @@
               <a:defRPr sz="3200"/>
             </a:pPr>
             <a:r>
-              <a:t>Hardware Specifications (HW Roadmap)</a:t>
+              <a:t>Pricing and Operational Costs</a:t>
             </a:r>
           </a:p>
         </p:txBody>
@@ -3246,7 +3246,7 @@
               <a:defRPr sz="1700"/>
             </a:pPr>
             <a:r>
-              <a:t>Standard (RTX 3060 12GB, 32GB RAM): For thousands of pages</a:t>
+              <a:t>One-time setup: 2,800 – 6,400 EUR (HW included)</a:t>
             </a:r>
           </a:p>
           <a:p>
@@ -3254,7 +3254,7 @@
               <a:defRPr sz="1700"/>
             </a:pPr>
             <a:r>
-              <a:t>Enterprise (RTX 4090 24GB, 64GB+ RAM): For large corporate archives</a:t>
+              <a:t>Monthly maintenance: 0 EUR (Self-hosted mode)</a:t>
             </a:r>
           </a:p>
           <a:p>
@@ -3262,7 +3262,7 @@
               <a:defRPr sz="1700"/>
             </a:pPr>
             <a:r>
-              <a:t>SSD: 1TB - 4TB NVMe for quick database retrieval</a:t>
+              <a:t>Software Updates &amp; Expert Support: Optional (On-demand)</a:t>
             </a:r>
           </a:p>
           <a:p>
@@ -3270,15 +3270,7 @@
               <a:defRPr sz="1700"/>
             </a:pPr>
             <a:r>
-              <a:t>OS: Ubuntu 22.04 LTS (Hardened &amp; Optimized distribution)</a:t>
-            </a:r>
-          </a:p>
-          <a:p>
-            <a:pPr>
-              <a:defRPr sz="1700"/>
-            </a:pPr>
-            <a:r>
-              <a:t>NVIDIA CUDA: Full optimization for local LLM engines</a:t>
+              <a:t>ROI (Return on Investment): Within 6 months</a:t>
             </a:r>
           </a:p>
         </p:txBody>
@@ -5010,7 +5002,7 @@
               <a:defRPr sz="3200"/>
             </a:pPr>
             <a:r>
-              <a:t>Pricing and Operational Costs</a:t>
+              <a:t>Turnkey Solution (HW + SW)</a:t>
             </a:r>
           </a:p>
         </p:txBody>
@@ -5035,7 +5027,7 @@
               <a:defRPr sz="1700"/>
             </a:pPr>
             <a:r>
-              <a:t>One-time setup: 2,800 – 6,400 EUR (HW included)</a:t>
+              <a:t>Full delivery including optimized AI workstation</a:t>
             </a:r>
           </a:p>
           <a:p>
@@ -5043,7 +5035,7 @@
               <a:defRPr sz="1700"/>
             </a:pPr>
             <a:r>
-              <a:t>Monthly maintenance: 0 EUR (Self-hosted mode)</a:t>
+              <a:t>Fully pre-installed and configured system (Plug &amp; Play)</a:t>
             </a:r>
           </a:p>
           <a:p>
@@ -5051,7 +5043,7 @@
               <a:defRPr sz="1700"/>
             </a:pPr>
             <a:r>
-              <a:t>Software Updates &amp; Expert Support: Optional (On-demand)</a:t>
+              <a:t>Maximum Security: Offline operation (Air-Gapped) supported</a:t>
             </a:r>
           </a:p>
           <a:p>
@@ -5059,7 +5051,7 @@
               <a:defRPr sz="1700"/>
             </a:pPr>
             <a:r>
-              <a:t>ROI (Return on Investment): Within 6 months</a:t>
+              <a:t>Guaranteed software compatibility with supplied hardware</a:t>
             </a:r>
           </a:p>
         </p:txBody>
@@ -5206,7 +5198,7 @@
               <a:defRPr sz="3200"/>
             </a:pPr>
             <a:r>
-              <a:t>Turnkey Solution (HW + SW)</a:t>
+              <a:t>Hardware Specifications (HW Roadmap)</a:t>
             </a:r>
           </a:p>
         </p:txBody>
@@ -5231,7 +5223,7 @@
               <a:defRPr sz="1700"/>
             </a:pPr>
             <a:r>
-              <a:t>Full delivery including optimized AI workstation</a:t>
+              <a:t>Standard (RTX 3060 12GB, 32GB RAM): For thousands of pages</a:t>
             </a:r>
           </a:p>
           <a:p>
@@ -5239,7 +5231,7 @@
               <a:defRPr sz="1700"/>
             </a:pPr>
             <a:r>
-              <a:t>Fully pre-installed and configured system (Plug &amp; Play)</a:t>
+              <a:t>Enterprise (RTX 4090 24GB, 64GB+ RAM): For large corporate archives</a:t>
             </a:r>
           </a:p>
           <a:p>
@@ -5247,7 +5239,7 @@
               <a:defRPr sz="1700"/>
             </a:pPr>
             <a:r>
-              <a:t>Maximum Security: Offline operation (Air-Gapped) supported</a:t>
+              <a:t>SSD: 1TB - 4TB NVMe for quick database retrieval</a:t>
             </a:r>
           </a:p>
           <a:p>
@@ -5255,7 +5247,15 @@
               <a:defRPr sz="1700"/>
             </a:pPr>
             <a:r>
-              <a:t>Guaranteed software compatibility with supplied hardware</a:t>
+              <a:t>OS: Ubuntu 22.04 LTS (Hardened &amp; Optimized distribution)</a:t>
+            </a:r>
+          </a:p>
+          <a:p>
+            <a:pPr>
+              <a:defRPr sz="1700"/>
+            </a:pPr>
+            <a:r>
+              <a:t>NVIDIA CUDA: Full optimization for local LLM engines</a:t>
             </a:r>
           </a:p>
         </p:txBody>

</xml_diff>